<commit_message>
Create VIEPS UI Concept 1
</commit_message>
<xml_diff>
--- a/5-Implementation-Projects/internet/cloudflare/jagports/vieps/VIEPS UI/VIEPS UI.pptx
+++ b/5-Implementation-Projects/internet/cloudflare/jagports/vieps/VIEPS UI/VIEPS UI.pptx
@@ -5,9 +5,10 @@
     <p:sldMasterId id="2147483648" r:id="rId1"/>
   </p:sldMasterIdLst>
   <p:sldIdLst>
-    <p:sldId id="256" r:id="rId2"/>
-    <p:sldId id="257" r:id="rId3"/>
-    <p:sldId id="258" r:id="rId4"/>
+    <p:sldId id="259" r:id="rId2"/>
+    <p:sldId id="256" r:id="rId3"/>
+    <p:sldId id="257" r:id="rId4"/>
+    <p:sldId id="258" r:id="rId5"/>
   </p:sldIdLst>
   <p:sldSz cx="12192000" cy="6858000"/>
   <p:notesSz cx="6858000" cy="9144000"/>
@@ -106,13 +107,18 @@
       </a:defRPr>
     </a:lvl9pPr>
   </p:defaultTextStyle>
+  <p:extLst>
+    <p:ext uri="{EFAFB233-063F-42B5-8137-9DF3F51BA10A}">
+      <p15:sldGuideLst xmlns:p15="http://schemas.microsoft.com/office/powerpoint/2012/main"/>
+    </p:ext>
+  </p:extLst>
 </p:presentation>
 </file>
 
 <file path=ppt/revisionInfo.xml><?xml version="1.0" encoding="utf-8"?>
 <p1510:revInfo xmlns:a="http://schemas.openxmlformats.org/drawingml/2006/main" xmlns:r="http://schemas.openxmlformats.org/officeDocument/2006/relationships" xmlns:p1510="http://schemas.microsoft.com/office/powerpoint/2015/10/main">
   <p1510:revLst>
-    <p1510:client id="{A730729C-4AD6-4CF8-B0BE-9DBCBC776536}" v="12" dt="2026-09-04T01:11:15.351"/>
+    <p1510:client id="{6D4DD72F-47BA-47F6-8610-D3EC2FE25F09}" v="1" dt="2026-09-10T02:05:28.696"/>
   </p1510:revLst>
 </p1510:revInfo>
 </file>
@@ -121,8 +127,8 @@
 <pc:chgInfo xmlns:a="http://schemas.openxmlformats.org/drawingml/2006/main" xmlns:r="http://schemas.openxmlformats.org/officeDocument/2006/relationships" xmlns:ac="http://schemas.microsoft.com/office/drawing/2013/main/command" xmlns:pc="http://schemas.microsoft.com/office/powerpoint/2013/main/command">
   <pc:docChgLst>
     <pc:chgData name="Tomi Lind" userId="8de46aee-b41d-491b-a3c8-daf1b5776a2e" providerId="ADAL" clId="{DA4176E6-4A74-4541-B8FC-EC14009AAF7D}"/>
-    <pc:docChg chg="undo custSel addSld modSld">
-      <pc:chgData name="Tomi Lind" userId="8de46aee-b41d-491b-a3c8-daf1b5776a2e" providerId="ADAL" clId="{DA4176E6-4A74-4541-B8FC-EC14009AAF7D}" dt="2026-09-04T01:25:53.901" v="651" actId="14100"/>
+    <pc:docChg chg="undo custSel addSld modSld sldOrd">
+      <pc:chgData name="Tomi Lind" userId="8de46aee-b41d-491b-a3c8-daf1b5776a2e" providerId="ADAL" clId="{DA4176E6-4A74-4541-B8FC-EC14009AAF7D}" dt="2026-09-10T02:09:19.536" v="701" actId="1076"/>
       <pc:docMkLst>
         <pc:docMk/>
       </pc:docMkLst>
@@ -132,30 +138,6 @@
           <pc:docMk/>
           <pc:sldMk cId="3629894088" sldId="256"/>
         </pc:sldMkLst>
-        <pc:spChg chg="del">
-          <ac:chgData name="Tomi Lind" userId="8de46aee-b41d-491b-a3c8-daf1b5776a2e" providerId="ADAL" clId="{DA4176E6-4A74-4541-B8FC-EC14009AAF7D}" dt="2026-09-03T23:58:26.340" v="1" actId="478"/>
-          <ac:spMkLst>
-            <pc:docMk/>
-            <pc:sldMk cId="3629894088" sldId="256"/>
-            <ac:spMk id="2" creationId="{4E942987-8D74-39F1-E418-35EEDB9E8691}"/>
-          </ac:spMkLst>
-        </pc:spChg>
-        <pc:spChg chg="del">
-          <ac:chgData name="Tomi Lind" userId="8de46aee-b41d-491b-a3c8-daf1b5776a2e" providerId="ADAL" clId="{DA4176E6-4A74-4541-B8FC-EC14009AAF7D}" dt="2026-09-03T23:58:29.085" v="2" actId="478"/>
-          <ac:spMkLst>
-            <pc:docMk/>
-            <pc:sldMk cId="3629894088" sldId="256"/>
-            <ac:spMk id="3" creationId="{4D95838A-6B0F-1635-3B98-F6C73CFD7117}"/>
-          </ac:spMkLst>
-        </pc:spChg>
-        <pc:spChg chg="add del mod">
-          <ac:chgData name="Tomi Lind" userId="8de46aee-b41d-491b-a3c8-daf1b5776a2e" providerId="ADAL" clId="{DA4176E6-4A74-4541-B8FC-EC14009AAF7D}" dt="2026-09-04T00:06:12.247" v="123"/>
-          <ac:spMkLst>
-            <pc:docMk/>
-            <pc:sldMk cId="3629894088" sldId="256"/>
-            <ac:spMk id="19" creationId="{AFC1B12B-6990-2FEB-1127-6A4254F477BD}"/>
-          </ac:spMkLst>
-        </pc:spChg>
         <pc:spChg chg="add mod">
           <ac:chgData name="Tomi Lind" userId="8de46aee-b41d-491b-a3c8-daf1b5776a2e" providerId="ADAL" clId="{DA4176E6-4A74-4541-B8FC-EC14009AAF7D}" dt="2026-09-04T01:08:25.974" v="303" actId="1076"/>
           <ac:spMkLst>
@@ -164,36 +146,12 @@
             <ac:spMk id="21" creationId="{AD9849FD-388C-9D95-EE93-4992E36D7939}"/>
           </ac:spMkLst>
         </pc:spChg>
-        <pc:spChg chg="add del mod">
-          <ac:chgData name="Tomi Lind" userId="8de46aee-b41d-491b-a3c8-daf1b5776a2e" providerId="ADAL" clId="{DA4176E6-4A74-4541-B8FC-EC14009AAF7D}" dt="2026-09-04T01:03:20.699" v="248" actId="478"/>
-          <ac:spMkLst>
-            <pc:docMk/>
-            <pc:sldMk cId="3629894088" sldId="256"/>
-            <ac:spMk id="23" creationId="{48C4B5E2-6087-DAFA-2120-ADF9BA893697}"/>
-          </ac:spMkLst>
-        </pc:spChg>
-        <pc:spChg chg="add del mod">
-          <ac:chgData name="Tomi Lind" userId="8de46aee-b41d-491b-a3c8-daf1b5776a2e" providerId="ADAL" clId="{DA4176E6-4A74-4541-B8FC-EC14009AAF7D}" dt="2026-09-04T01:03:39.975" v="250" actId="478"/>
-          <ac:spMkLst>
-            <pc:docMk/>
-            <pc:sldMk cId="3629894088" sldId="256"/>
-            <ac:spMk id="25" creationId="{BF37BDD9-A351-5746-70AF-C7884F3EE1B2}"/>
-          </ac:spMkLst>
-        </pc:spChg>
         <pc:spChg chg="add mod">
           <ac:chgData name="Tomi Lind" userId="8de46aee-b41d-491b-a3c8-daf1b5776a2e" providerId="ADAL" clId="{DA4176E6-4A74-4541-B8FC-EC14009AAF7D}" dt="2026-09-04T01:00:12.638" v="203" actId="164"/>
           <ac:spMkLst>
             <pc:docMk/>
             <pc:sldMk cId="3629894088" sldId="256"/>
             <ac:spMk id="26" creationId="{36C2719A-18CE-2059-A009-58103DF2700C}"/>
-          </ac:spMkLst>
-        </pc:spChg>
-        <pc:spChg chg="del mod topLvl">
-          <ac:chgData name="Tomi Lind" userId="8de46aee-b41d-491b-a3c8-daf1b5776a2e" providerId="ADAL" clId="{DA4176E6-4A74-4541-B8FC-EC14009AAF7D}" dt="2026-09-04T01:05:27.873" v="263" actId="478"/>
-          <ac:spMkLst>
-            <pc:docMk/>
-            <pc:sldMk cId="3629894088" sldId="256"/>
-            <ac:spMk id="40" creationId="{880785D2-5EBA-7C7C-8B5B-07283F43B5B6}"/>
           </ac:spMkLst>
         </pc:spChg>
         <pc:spChg chg="add mod">
@@ -228,14 +186,6 @@
             <ac:grpSpMk id="35" creationId="{64F173F8-0BDF-4EF9-A396-1EC172C3441A}"/>
           </ac:grpSpMkLst>
         </pc:grpChg>
-        <pc:grpChg chg="add del mod">
-          <ac:chgData name="Tomi Lind" userId="8de46aee-b41d-491b-a3c8-daf1b5776a2e" providerId="ADAL" clId="{DA4176E6-4A74-4541-B8FC-EC14009AAF7D}" dt="2026-09-04T01:05:24.857" v="262" actId="165"/>
-          <ac:grpSpMkLst>
-            <pc:docMk/>
-            <pc:sldMk cId="3629894088" sldId="256"/>
-            <ac:grpSpMk id="38" creationId="{F7F6EAAB-D592-CC2B-D18C-DAB9BC9CB858}"/>
-          </ac:grpSpMkLst>
-        </pc:grpChg>
         <pc:grpChg chg="add mod">
           <ac:chgData name="Tomi Lind" userId="8de46aee-b41d-491b-a3c8-daf1b5776a2e" providerId="ADAL" clId="{DA4176E6-4A74-4541-B8FC-EC14009AAF7D}" dt="2026-09-04T01:10:29.981" v="339" actId="1076"/>
           <ac:grpSpMkLst>
@@ -244,44 +194,12 @@
             <ac:grpSpMk id="47" creationId="{F061092C-AB6C-6C43-0A5E-21E6DD2BC8B6}"/>
           </ac:grpSpMkLst>
         </pc:grpChg>
-        <pc:graphicFrameChg chg="add del mod">
-          <ac:chgData name="Tomi Lind" userId="8de46aee-b41d-491b-a3c8-daf1b5776a2e" providerId="ADAL" clId="{DA4176E6-4A74-4541-B8FC-EC14009AAF7D}" dt="2026-09-04T00:03:49.668" v="37" actId="478"/>
-          <ac:graphicFrameMkLst>
-            <pc:docMk/>
-            <pc:sldMk cId="3629894088" sldId="256"/>
-            <ac:graphicFrameMk id="16" creationId="{CDBB51FB-29A7-4FBB-DF5C-EBD3DA78D5C2}"/>
-          </ac:graphicFrameMkLst>
-        </pc:graphicFrameChg>
-        <pc:picChg chg="add del mod">
-          <ac:chgData name="Tomi Lind" userId="8de46aee-b41d-491b-a3c8-daf1b5776a2e" providerId="ADAL" clId="{DA4176E6-4A74-4541-B8FC-EC14009AAF7D}" dt="2026-09-04T00:01:00.419" v="18" actId="478"/>
-          <ac:picMkLst>
-            <pc:docMk/>
-            <pc:sldMk cId="3629894088" sldId="256"/>
-            <ac:picMk id="5" creationId="{4E0496E2-3631-0DE4-2347-19D37C807218}"/>
-          </ac:picMkLst>
-        </pc:picChg>
         <pc:picChg chg="add mod modCrop">
           <ac:chgData name="Tomi Lind" userId="8de46aee-b41d-491b-a3c8-daf1b5776a2e" providerId="ADAL" clId="{DA4176E6-4A74-4541-B8FC-EC14009AAF7D}" dt="2026-09-04T01:05:09.981" v="260" actId="732"/>
           <ac:picMkLst>
             <pc:docMk/>
             <pc:sldMk cId="3629894088" sldId="256"/>
             <ac:picMk id="7" creationId="{2D5E44A3-82CB-67C5-4137-A3576E9E81DE}"/>
-          </ac:picMkLst>
-        </pc:picChg>
-        <pc:picChg chg="add del mod">
-          <ac:chgData name="Tomi Lind" userId="8de46aee-b41d-491b-a3c8-daf1b5776a2e" providerId="ADAL" clId="{DA4176E6-4A74-4541-B8FC-EC14009AAF7D}" dt="2026-09-04T00:00:58.902" v="17" actId="478"/>
-          <ac:picMkLst>
-            <pc:docMk/>
-            <pc:sldMk cId="3629894088" sldId="256"/>
-            <ac:picMk id="9" creationId="{38FCCB52-9EAD-C4C8-B07F-270E5ED9DA9E}"/>
-          </ac:picMkLst>
-        </pc:picChg>
-        <pc:picChg chg="add del mod">
-          <ac:chgData name="Tomi Lind" userId="8de46aee-b41d-491b-a3c8-daf1b5776a2e" providerId="ADAL" clId="{DA4176E6-4A74-4541-B8FC-EC14009AAF7D}" dt="2026-09-04T00:02:57.873" v="26" actId="478"/>
-          <ac:picMkLst>
-            <pc:docMk/>
-            <pc:sldMk cId="3629894088" sldId="256"/>
-            <ac:picMk id="11" creationId="{D59F6FF7-42C4-F311-E4CB-50A7E32B4BC0}"/>
           </ac:picMkLst>
         </pc:picChg>
         <pc:picChg chg="add mod modCrop">
@@ -298,30 +216,6 @@
             <pc:docMk/>
             <pc:sldMk cId="3629894088" sldId="256"/>
             <ac:picMk id="15" creationId="{9BD7EE9F-93A4-171B-B0BC-6143C23324AE}"/>
-          </ac:picMkLst>
-        </pc:picChg>
-        <pc:picChg chg="add mod">
-          <ac:chgData name="Tomi Lind" userId="8de46aee-b41d-491b-a3c8-daf1b5776a2e" providerId="ADAL" clId="{DA4176E6-4A74-4541-B8FC-EC14009AAF7D}" dt="2026-09-04T00:03:43.231" v="36" actId="1076"/>
-          <ac:picMkLst>
-            <pc:docMk/>
-            <pc:sldMk cId="3629894088" sldId="256"/>
-            <ac:picMk id="17" creationId="{B0B7D4B3-1208-E393-CBBA-8ECDFA66535F}"/>
-          </ac:picMkLst>
-        </pc:picChg>
-        <pc:picChg chg="add del mod">
-          <ac:chgData name="Tomi Lind" userId="8de46aee-b41d-491b-a3c8-daf1b5776a2e" providerId="ADAL" clId="{DA4176E6-4A74-4541-B8FC-EC14009AAF7D}" dt="2026-09-04T00:08:37.122" v="166" actId="478"/>
-          <ac:picMkLst>
-            <pc:docMk/>
-            <pc:sldMk cId="3629894088" sldId="256"/>
-            <ac:picMk id="28" creationId="{0F489629-F217-474F-4E06-5D5F2CDBEECC}"/>
-          </ac:picMkLst>
-        </pc:picChg>
-        <pc:picChg chg="add del mod modCrop">
-          <ac:chgData name="Tomi Lind" userId="8de46aee-b41d-491b-a3c8-daf1b5776a2e" providerId="ADAL" clId="{DA4176E6-4A74-4541-B8FC-EC14009AAF7D}" dt="2026-09-04T00:57:44.011" v="174" actId="478"/>
-          <ac:picMkLst>
-            <pc:docMk/>
-            <pc:sldMk cId="3629894088" sldId="256"/>
-            <ac:picMk id="30" creationId="{11780FAF-DFB0-A04F-06EB-1E7C45E1FBC4}"/>
           </ac:picMkLst>
         </pc:picChg>
         <pc:picChg chg="add mod">
@@ -363,14 +257,6 @@
           <pc:docMk/>
           <pc:sldMk cId="4210487034" sldId="257"/>
         </pc:sldMkLst>
-        <pc:spChg chg="add del mod">
-          <ac:chgData name="Tomi Lind" userId="8de46aee-b41d-491b-a3c8-daf1b5776a2e" providerId="ADAL" clId="{DA4176E6-4A74-4541-B8FC-EC14009AAF7D}" dt="2026-09-04T01:12:16.372" v="412"/>
-          <ac:spMkLst>
-            <pc:docMk/>
-            <pc:sldMk cId="4210487034" sldId="257"/>
-            <ac:spMk id="2" creationId="{7612E008-2EF7-47D6-A837-EADD1BE77677}"/>
-          </ac:spMkLst>
-        </pc:spChg>
         <pc:spChg chg="add mod">
           <ac:chgData name="Tomi Lind" userId="8de46aee-b41d-491b-a3c8-daf1b5776a2e" providerId="ADAL" clId="{DA4176E6-4A74-4541-B8FC-EC14009AAF7D}" dt="2026-09-04T01:14:09.184" v="460" actId="207"/>
           <ac:spMkLst>
@@ -393,14 +279,6 @@
             <pc:docMk/>
             <pc:sldMk cId="4210487034" sldId="257"/>
             <ac:spMk id="8" creationId="{47EEBB80-611D-75DB-9C11-AFD8A8E1602E}"/>
-          </ac:spMkLst>
-        </pc:spChg>
-        <pc:spChg chg="add del">
-          <ac:chgData name="Tomi Lind" userId="8de46aee-b41d-491b-a3c8-daf1b5776a2e" providerId="ADAL" clId="{DA4176E6-4A74-4541-B8FC-EC14009AAF7D}" dt="2026-09-04T01:12:24.077" v="416" actId="22"/>
-          <ac:spMkLst>
-            <pc:docMk/>
-            <pc:sldMk cId="4210487034" sldId="257"/>
-            <ac:spMk id="10" creationId="{F1B68594-1921-A960-CE86-AB2E1ED01547}"/>
           </ac:spMkLst>
         </pc:spChg>
         <pc:spChg chg="add mod">
@@ -443,14 +321,6 @@
             <ac:spMk id="21" creationId="{A92CE113-61A7-C569-1DF0-81293841D7E8}"/>
           </ac:spMkLst>
         </pc:spChg>
-        <pc:grpChg chg="del">
-          <ac:chgData name="Tomi Lind" userId="8de46aee-b41d-491b-a3c8-daf1b5776a2e" providerId="ADAL" clId="{DA4176E6-4A74-4541-B8FC-EC14009AAF7D}" dt="2026-09-04T01:07:29.798" v="285" actId="478"/>
-          <ac:grpSpMkLst>
-            <pc:docMk/>
-            <pc:sldMk cId="4210487034" sldId="257"/>
-            <ac:grpSpMk id="35" creationId="{05D6795C-CAE6-8A26-8FD6-7A85363EF0B0}"/>
-          </ac:grpSpMkLst>
-        </pc:grpChg>
         <pc:grpChg chg="mod">
           <ac:chgData name="Tomi Lind" userId="8de46aee-b41d-491b-a3c8-daf1b5776a2e" providerId="ADAL" clId="{DA4176E6-4A74-4541-B8FC-EC14009AAF7D}" dt="2026-09-04T01:11:55.668" v="392" actId="1076"/>
           <ac:grpSpMkLst>
@@ -459,14 +329,6 @@
             <ac:grpSpMk id="47" creationId="{0F871743-C1EB-0388-3B1F-2F425BB8A324}"/>
           </ac:grpSpMkLst>
         </pc:grpChg>
-        <pc:picChg chg="del">
-          <ac:chgData name="Tomi Lind" userId="8de46aee-b41d-491b-a3c8-daf1b5776a2e" providerId="ADAL" clId="{DA4176E6-4A74-4541-B8FC-EC14009AAF7D}" dt="2026-09-04T01:07:29.798" v="285" actId="478"/>
-          <ac:picMkLst>
-            <pc:docMk/>
-            <pc:sldMk cId="4210487034" sldId="257"/>
-            <ac:picMk id="7" creationId="{76E22A04-2601-4FA7-EEF5-48BDF0D7B9C8}"/>
-          </ac:picMkLst>
-        </pc:picChg>
         <pc:picChg chg="mod">
           <ac:chgData name="Tomi Lind" userId="8de46aee-b41d-491b-a3c8-daf1b5776a2e" providerId="ADAL" clId="{DA4176E6-4A74-4541-B8FC-EC14009AAF7D}" dt="2026-09-04T01:11:31.278" v="365" actId="1076"/>
           <ac:picMkLst>
@@ -602,22 +464,6 @@
             <ac:picMk id="10" creationId="{8684F8B4-8BEC-CCDC-1FFB-F77109465BB0}"/>
           </ac:picMkLst>
         </pc:picChg>
-        <pc:picChg chg="del mod">
-          <ac:chgData name="Tomi Lind" userId="8de46aee-b41d-491b-a3c8-daf1b5776a2e" providerId="ADAL" clId="{DA4176E6-4A74-4541-B8FC-EC14009AAF7D}" dt="2026-09-04T01:21:00.340" v="631" actId="478"/>
-          <ac:picMkLst>
-            <pc:docMk/>
-            <pc:sldMk cId="452807913" sldId="258"/>
-            <ac:picMk id="13" creationId="{287F1B88-AF33-BD21-BE2F-B537DE762934}"/>
-          </ac:picMkLst>
-        </pc:picChg>
-        <pc:picChg chg="del">
-          <ac:chgData name="Tomi Lind" userId="8de46aee-b41d-491b-a3c8-daf1b5776a2e" providerId="ADAL" clId="{DA4176E6-4A74-4541-B8FC-EC14009AAF7D}" dt="2026-09-04T01:18:15.462" v="533" actId="478"/>
-          <ac:picMkLst>
-            <pc:docMk/>
-            <pc:sldMk cId="452807913" sldId="258"/>
-            <ac:picMk id="15" creationId="{F8609F98-5BF2-969A-9696-5B436DAF12A9}"/>
-          </ac:picMkLst>
-        </pc:picChg>
         <pc:picChg chg="add mod modCrop">
           <ac:chgData name="Tomi Lind" userId="8de46aee-b41d-491b-a3c8-daf1b5776a2e" providerId="ADAL" clId="{DA4176E6-4A74-4541-B8FC-EC14009AAF7D}" dt="2026-09-04T01:19:46.199" v="571" actId="1035"/>
           <ac:picMkLst>
@@ -667,6 +513,101 @@
           </ac:picMkLst>
         </pc:picChg>
       </pc:sldChg>
+      <pc:sldChg chg="modSp add mod ord">
+        <pc:chgData name="Tomi Lind" userId="8de46aee-b41d-491b-a3c8-daf1b5776a2e" providerId="ADAL" clId="{DA4176E6-4A74-4541-B8FC-EC14009AAF7D}" dt="2026-09-10T02:09:19.536" v="701" actId="1076"/>
+        <pc:sldMkLst>
+          <pc:docMk/>
+          <pc:sldMk cId="1388509897" sldId="259"/>
+        </pc:sldMkLst>
+        <pc:spChg chg="mod">
+          <ac:chgData name="Tomi Lind" userId="8de46aee-b41d-491b-a3c8-daf1b5776a2e" providerId="ADAL" clId="{DA4176E6-4A74-4541-B8FC-EC14009AAF7D}" dt="2026-09-10T02:08:41.632" v="679" actId="1076"/>
+          <ac:spMkLst>
+            <pc:docMk/>
+            <pc:sldMk cId="1388509897" sldId="259"/>
+            <ac:spMk id="2" creationId="{C4CE6B41-E4B8-CFCC-62E0-F5ECF165721C}"/>
+          </ac:spMkLst>
+        </pc:spChg>
+        <pc:spChg chg="mod">
+          <ac:chgData name="Tomi Lind" userId="8de46aee-b41d-491b-a3c8-daf1b5776a2e" providerId="ADAL" clId="{DA4176E6-4A74-4541-B8FC-EC14009AAF7D}" dt="2026-09-10T02:09:06.209" v="698" actId="20577"/>
+          <ac:spMkLst>
+            <pc:docMk/>
+            <pc:sldMk cId="1388509897" sldId="259"/>
+            <ac:spMk id="5" creationId="{23532A01-223B-A6C7-014B-B2FB1D8D6A5C}"/>
+          </ac:spMkLst>
+        </pc:spChg>
+        <pc:spChg chg="mod">
+          <ac:chgData name="Tomi Lind" userId="8de46aee-b41d-491b-a3c8-daf1b5776a2e" providerId="ADAL" clId="{DA4176E6-4A74-4541-B8FC-EC14009AAF7D}" dt="2026-09-10T02:09:09.951" v="699" actId="1076"/>
+          <ac:spMkLst>
+            <pc:docMk/>
+            <pc:sldMk cId="1388509897" sldId="259"/>
+            <ac:spMk id="8" creationId="{F4F5DBDF-2412-7614-B3C5-ECFD73253A87}"/>
+          </ac:spMkLst>
+        </pc:spChg>
+        <pc:spChg chg="mod">
+          <ac:chgData name="Tomi Lind" userId="8de46aee-b41d-491b-a3c8-daf1b5776a2e" providerId="ADAL" clId="{DA4176E6-4A74-4541-B8FC-EC14009AAF7D}" dt="2026-09-10T02:09:19.536" v="701" actId="1076"/>
+          <ac:spMkLst>
+            <pc:docMk/>
+            <pc:sldMk cId="1388509897" sldId="259"/>
+            <ac:spMk id="10" creationId="{BACA329E-367A-5819-5C26-75A94A008574}"/>
+          </ac:spMkLst>
+        </pc:spChg>
+        <pc:spChg chg="mod">
+          <ac:chgData name="Tomi Lind" userId="8de46aee-b41d-491b-a3c8-daf1b5776a2e" providerId="ADAL" clId="{DA4176E6-4A74-4541-B8FC-EC14009AAF7D}" dt="2026-09-10T02:08:44.369" v="680" actId="1076"/>
+          <ac:spMkLst>
+            <pc:docMk/>
+            <pc:sldMk cId="1388509897" sldId="259"/>
+            <ac:spMk id="12" creationId="{150E95DA-FF3E-54C7-E8B5-8FA7445FA6C8}"/>
+          </ac:spMkLst>
+        </pc:spChg>
+        <pc:spChg chg="mod">
+          <ac:chgData name="Tomi Lind" userId="8de46aee-b41d-491b-a3c8-daf1b5776a2e" providerId="ADAL" clId="{DA4176E6-4A74-4541-B8FC-EC14009AAF7D}" dt="2026-09-10T02:08:41.632" v="679" actId="1076"/>
+          <ac:spMkLst>
+            <pc:docMk/>
+            <pc:sldMk cId="1388509897" sldId="259"/>
+            <ac:spMk id="16" creationId="{9F71D180-810F-6A5D-42B5-6CE7AC5FFE2F}"/>
+          </ac:spMkLst>
+        </pc:spChg>
+        <pc:spChg chg="mod">
+          <ac:chgData name="Tomi Lind" userId="8de46aee-b41d-491b-a3c8-daf1b5776a2e" providerId="ADAL" clId="{DA4176E6-4A74-4541-B8FC-EC14009AAF7D}" dt="2026-09-10T02:07:56.720" v="674" actId="1076"/>
+          <ac:spMkLst>
+            <pc:docMk/>
+            <pc:sldMk cId="1388509897" sldId="259"/>
+            <ac:spMk id="21" creationId="{AD9849FD-388C-9D95-EE93-4992E36D7939}"/>
+          </ac:spMkLst>
+        </pc:spChg>
+        <pc:picChg chg="mod">
+          <ac:chgData name="Tomi Lind" userId="8de46aee-b41d-491b-a3c8-daf1b5776a2e" providerId="ADAL" clId="{DA4176E6-4A74-4541-B8FC-EC14009AAF7D}" dt="2026-09-10T02:08:51.247" v="681" actId="1076"/>
+          <ac:picMkLst>
+            <pc:docMk/>
+            <pc:sldMk cId="1388509897" sldId="259"/>
+            <ac:picMk id="13" creationId="{917D9344-98BA-1301-286A-B95D2C81DE37}"/>
+          </ac:picMkLst>
+        </pc:picChg>
+        <pc:picChg chg="mod">
+          <ac:chgData name="Tomi Lind" userId="8de46aee-b41d-491b-a3c8-daf1b5776a2e" providerId="ADAL" clId="{DA4176E6-4A74-4541-B8FC-EC14009AAF7D}" dt="2026-09-10T02:09:12.456" v="700" actId="1076"/>
+          <ac:picMkLst>
+            <pc:docMk/>
+            <pc:sldMk cId="1388509897" sldId="259"/>
+            <ac:picMk id="15" creationId="{9BD7EE9F-93A4-171B-B0BC-6143C23324AE}"/>
+          </ac:picMkLst>
+        </pc:picChg>
+        <pc:picChg chg="mod">
+          <ac:chgData name="Tomi Lind" userId="8de46aee-b41d-491b-a3c8-daf1b5776a2e" providerId="ADAL" clId="{DA4176E6-4A74-4541-B8FC-EC14009AAF7D}" dt="2026-09-10T02:06:35.463" v="660" actId="1076"/>
+          <ac:picMkLst>
+            <pc:docMk/>
+            <pc:sldMk cId="1388509897" sldId="259"/>
+            <ac:picMk id="32" creationId="{C5A30AB2-A780-3DD0-CD13-995A1653E154}"/>
+          </ac:picMkLst>
+        </pc:picChg>
+        <pc:picChg chg="mod">
+          <ac:chgData name="Tomi Lind" userId="8de46aee-b41d-491b-a3c8-daf1b5776a2e" providerId="ADAL" clId="{DA4176E6-4A74-4541-B8FC-EC14009AAF7D}" dt="2026-09-10T02:06:35.463" v="660" actId="1076"/>
+          <ac:picMkLst>
+            <pc:docMk/>
+            <pc:sldMk cId="1388509897" sldId="259"/>
+            <ac:picMk id="34" creationId="{1F5037B9-6B59-85AA-D13C-3367BB9D392E}"/>
+          </ac:picMkLst>
+        </pc:picChg>
+      </pc:sldChg>
     </pc:docChg>
   </pc:docChgLst>
 </pc:chgInfo>
@@ -821,7 +762,7 @@
           <a:p>
             <a:fld id="{E0079C93-06BA-4335-A3D1-B6B7CD2840E1}" type="datetimeFigureOut">
               <a:rPr lang="LID4096" smtClean="0"/>
-              <a:t>09/04/2026</a:t>
+              <a:t>09/10/2026</a:t>
             </a:fld>
             <a:endParaRPr lang="LID4096"/>
           </a:p>
@@ -1021,7 +962,7 @@
           <a:p>
             <a:fld id="{E0079C93-06BA-4335-A3D1-B6B7CD2840E1}" type="datetimeFigureOut">
               <a:rPr lang="LID4096" smtClean="0"/>
-              <a:t>09/04/2026</a:t>
+              <a:t>09/10/2026</a:t>
             </a:fld>
             <a:endParaRPr lang="LID4096"/>
           </a:p>
@@ -1231,7 +1172,7 @@
           <a:p>
             <a:fld id="{E0079C93-06BA-4335-A3D1-B6B7CD2840E1}" type="datetimeFigureOut">
               <a:rPr lang="LID4096" smtClean="0"/>
-              <a:t>09/04/2026</a:t>
+              <a:t>09/10/2026</a:t>
             </a:fld>
             <a:endParaRPr lang="LID4096"/>
           </a:p>
@@ -1431,7 +1372,7 @@
           <a:p>
             <a:fld id="{E0079C93-06BA-4335-A3D1-B6B7CD2840E1}" type="datetimeFigureOut">
               <a:rPr lang="LID4096" smtClean="0"/>
-              <a:t>09/04/2026</a:t>
+              <a:t>09/10/2026</a:t>
             </a:fld>
             <a:endParaRPr lang="LID4096"/>
           </a:p>
@@ -1707,7 +1648,7 @@
           <a:p>
             <a:fld id="{E0079C93-06BA-4335-A3D1-B6B7CD2840E1}" type="datetimeFigureOut">
               <a:rPr lang="LID4096" smtClean="0"/>
-              <a:t>09/04/2026</a:t>
+              <a:t>09/10/2026</a:t>
             </a:fld>
             <a:endParaRPr lang="LID4096"/>
           </a:p>
@@ -1975,7 +1916,7 @@
           <a:p>
             <a:fld id="{E0079C93-06BA-4335-A3D1-B6B7CD2840E1}" type="datetimeFigureOut">
               <a:rPr lang="LID4096" smtClean="0"/>
-              <a:t>09/04/2026</a:t>
+              <a:t>09/10/2026</a:t>
             </a:fld>
             <a:endParaRPr lang="LID4096"/>
           </a:p>
@@ -2390,7 +2331,7 @@
           <a:p>
             <a:fld id="{E0079C93-06BA-4335-A3D1-B6B7CD2840E1}" type="datetimeFigureOut">
               <a:rPr lang="LID4096" smtClean="0"/>
-              <a:t>09/04/2026</a:t>
+              <a:t>09/10/2026</a:t>
             </a:fld>
             <a:endParaRPr lang="LID4096"/>
           </a:p>
@@ -2532,7 +2473,7 @@
           <a:p>
             <a:fld id="{E0079C93-06BA-4335-A3D1-B6B7CD2840E1}" type="datetimeFigureOut">
               <a:rPr lang="LID4096" smtClean="0"/>
-              <a:t>09/04/2026</a:t>
+              <a:t>09/10/2026</a:t>
             </a:fld>
             <a:endParaRPr lang="LID4096"/>
           </a:p>
@@ -2645,7 +2586,7 @@
           <a:p>
             <a:fld id="{E0079C93-06BA-4335-A3D1-B6B7CD2840E1}" type="datetimeFigureOut">
               <a:rPr lang="LID4096" smtClean="0"/>
-              <a:t>09/04/2026</a:t>
+              <a:t>09/10/2026</a:t>
             </a:fld>
             <a:endParaRPr lang="LID4096"/>
           </a:p>
@@ -2958,7 +2899,7 @@
           <a:p>
             <a:fld id="{E0079C93-06BA-4335-A3D1-B6B7CD2840E1}" type="datetimeFigureOut">
               <a:rPr lang="LID4096" smtClean="0"/>
-              <a:t>09/04/2026</a:t>
+              <a:t>09/10/2026</a:t>
             </a:fld>
             <a:endParaRPr lang="LID4096"/>
           </a:p>
@@ -3247,7 +3188,7 @@
           <a:p>
             <a:fld id="{E0079C93-06BA-4335-A3D1-B6B7CD2840E1}" type="datetimeFigureOut">
               <a:rPr lang="LID4096" smtClean="0"/>
-              <a:t>09/04/2026</a:t>
+              <a:t>09/10/2026</a:t>
             </a:fld>
             <a:endParaRPr lang="LID4096"/>
           </a:p>
@@ -3490,7 +3431,7 @@
           <a:p>
             <a:fld id="{E0079C93-06BA-4335-A3D1-B6B7CD2840E1}" type="datetimeFigureOut">
               <a:rPr lang="LID4096" smtClean="0"/>
-              <a:t>09/04/2026</a:t>
+              <a:t>09/10/2026</a:t>
             </a:fld>
             <a:endParaRPr lang="LID4096"/>
           </a:p>
@@ -3930,6 +3871,732 @@
         </p:blipFill>
         <p:spPr>
           <a:xfrm>
+            <a:off x="4274712" y="3855328"/>
+            <a:ext cx="2368618" cy="2577168"/>
+          </a:xfrm>
+          <a:prstGeom prst="rect">
+            <a:avLst/>
+          </a:prstGeom>
+        </p:spPr>
+      </p:pic>
+      <p:pic>
+        <p:nvPicPr>
+          <p:cNvPr id="15" name="Picture 14">
+            <a:extLst>
+              <a:ext uri="{FF2B5EF4-FFF2-40B4-BE49-F238E27FC236}">
+                <a16:creationId xmlns:a16="http://schemas.microsoft.com/office/drawing/2014/main" id="{9BD7EE9F-93A4-171B-B0BC-6143C23324AE}"/>
+              </a:ext>
+            </a:extLst>
+          </p:cNvPr>
+          <p:cNvPicPr>
+            <a:picLocks noChangeAspect="1"/>
+          </p:cNvPicPr>
+          <p:nvPr/>
+        </p:nvPicPr>
+        <p:blipFill>
+          <a:blip r:embed="rId3"/>
+          <a:stretch>
+            <a:fillRect/>
+          </a:stretch>
+        </p:blipFill>
+        <p:spPr>
+          <a:xfrm>
+            <a:off x="8044038" y="1571362"/>
+            <a:ext cx="2180941" cy="4649027"/>
+          </a:xfrm>
+          <a:prstGeom prst="rect">
+            <a:avLst/>
+          </a:prstGeom>
+        </p:spPr>
+      </p:pic>
+      <p:sp>
+        <p:nvSpPr>
+          <p:cNvPr id="21" name="TextBox 20">
+            <a:extLst>
+              <a:ext uri="{FF2B5EF4-FFF2-40B4-BE49-F238E27FC236}">
+                <a16:creationId xmlns:a16="http://schemas.microsoft.com/office/drawing/2014/main" id="{AD9849FD-388C-9D95-EE93-4992E36D7939}"/>
+              </a:ext>
+            </a:extLst>
+          </p:cNvPr>
+          <p:cNvSpPr txBox="1"/>
+          <p:nvPr/>
+        </p:nvSpPr>
+        <p:spPr>
+          <a:xfrm>
+            <a:off x="2118633" y="175054"/>
+            <a:ext cx="6699442" cy="530915"/>
+          </a:xfrm>
+          <a:prstGeom prst="rect">
+            <a:avLst/>
+          </a:prstGeom>
+          <a:noFill/>
+        </p:spPr>
+        <p:txBody>
+          <a:bodyPr wrap="square">
+            <a:spAutoFit/>
+          </a:bodyPr>
+          <a:lstStyle/>
+          <a:p>
+            <a:pPr algn="ctr"/>
+            <a:r>
+              <a:rPr lang="en-US" dirty="0"/>
+              <a:t>Search part #: </a:t>
+            </a:r>
+            <a:r>
+              <a:rPr lang="LID4096" dirty="0"/>
+              <a:t>MJB7703AA</a:t>
+            </a:r>
+            <a:endParaRPr lang="en-US" dirty="0"/>
+          </a:p>
+          <a:p>
+            <a:r>
+              <a:rPr lang="en-US" sz="1050" dirty="0"/>
+              <a:t>[when empty update Model Ranges and suitability tree to show all models and main levels which parts stock has]</a:t>
+            </a:r>
+            <a:endParaRPr lang="LID4096" sz="1050" dirty="0"/>
+          </a:p>
+        </p:txBody>
+      </p:sp>
+      <p:pic>
+        <p:nvPicPr>
+          <p:cNvPr id="32" name="Picture 31">
+            <a:extLst>
+              <a:ext uri="{FF2B5EF4-FFF2-40B4-BE49-F238E27FC236}">
+                <a16:creationId xmlns:a16="http://schemas.microsoft.com/office/drawing/2014/main" id="{C5A30AB2-A780-3DD0-CD13-995A1653E154}"/>
+              </a:ext>
+            </a:extLst>
+          </p:cNvPr>
+          <p:cNvPicPr>
+            <a:picLocks noChangeAspect="1"/>
+          </p:cNvPicPr>
+          <p:nvPr/>
+        </p:nvPicPr>
+        <p:blipFill>
+          <a:blip r:embed="rId4"/>
+          <a:stretch>
+            <a:fillRect/>
+          </a:stretch>
+        </p:blipFill>
+        <p:spPr>
+          <a:xfrm>
+            <a:off x="487335" y="5404244"/>
+            <a:ext cx="2698044" cy="745067"/>
+          </a:xfrm>
+          <a:prstGeom prst="rect">
+            <a:avLst/>
+          </a:prstGeom>
+        </p:spPr>
+      </p:pic>
+      <p:pic>
+        <p:nvPicPr>
+          <p:cNvPr id="34" name="Graphic 33">
+            <a:extLst>
+              <a:ext uri="{FF2B5EF4-FFF2-40B4-BE49-F238E27FC236}">
+                <a16:creationId xmlns:a16="http://schemas.microsoft.com/office/drawing/2014/main" id="{1F5037B9-6B59-85AA-D13C-3367BB9D392E}"/>
+              </a:ext>
+            </a:extLst>
+          </p:cNvPr>
+          <p:cNvPicPr>
+            <a:picLocks noChangeAspect="1"/>
+          </p:cNvPicPr>
+          <p:nvPr/>
+        </p:nvPicPr>
+        <p:blipFill>
+          <a:blip>
+            <a:extLst>
+              <a:ext uri="{96DAC541-7B7A-43D3-8B79-37D633B846F1}">
+                <asvg:svgBlip xmlns:asvg="http://schemas.microsoft.com/office/drawing/2016/SVG/main" r:embed="rId5"/>
+              </a:ext>
+            </a:extLst>
+          </a:blip>
+          <a:stretch>
+            <a:fillRect/>
+          </a:stretch>
+        </p:blipFill>
+        <p:spPr>
+          <a:xfrm>
+            <a:off x="480279" y="4187464"/>
+            <a:ext cx="2705100" cy="1057275"/>
+          </a:xfrm>
+          <a:prstGeom prst="rect">
+            <a:avLst/>
+          </a:prstGeom>
+        </p:spPr>
+      </p:pic>
+      <p:sp>
+        <p:nvSpPr>
+          <p:cNvPr id="2" name="TextBox 1">
+            <a:extLst>
+              <a:ext uri="{FF2B5EF4-FFF2-40B4-BE49-F238E27FC236}">
+                <a16:creationId xmlns:a16="http://schemas.microsoft.com/office/drawing/2014/main" id="{C4CE6B41-E4B8-CFCC-62E0-F5ECF165721C}"/>
+              </a:ext>
+            </a:extLst>
+          </p:cNvPr>
+          <p:cNvSpPr txBox="1"/>
+          <p:nvPr/>
+        </p:nvSpPr>
+        <p:spPr>
+          <a:xfrm>
+            <a:off x="1002215" y="1391033"/>
+            <a:ext cx="1451038" cy="2092881"/>
+          </a:xfrm>
+          <a:prstGeom prst="rect">
+            <a:avLst/>
+          </a:prstGeom>
+          <a:noFill/>
+        </p:spPr>
+        <p:txBody>
+          <a:bodyPr wrap="none" rtlCol="0">
+            <a:spAutoFit/>
+          </a:bodyPr>
+          <a:lstStyle/>
+          <a:p>
+            <a:r>
+              <a:rPr lang="en-US" sz="1000" dirty="0"/>
+              <a:t>Jaguar Accessories</a:t>
+            </a:r>
+          </a:p>
+          <a:p>
+            <a:r>
+              <a:rPr lang="en-US" sz="1000" dirty="0"/>
+              <a:t>Daimler Limousine</a:t>
+            </a:r>
+          </a:p>
+          <a:p>
+            <a:r>
+              <a:rPr lang="en-US" sz="1000" dirty="0"/>
+              <a:t>E-Pace</a:t>
+            </a:r>
+          </a:p>
+          <a:p>
+            <a:r>
+              <a:rPr lang="en-US" sz="1000" dirty="0"/>
+              <a:t>E-Type</a:t>
+            </a:r>
+          </a:p>
+          <a:p>
+            <a:r>
+              <a:rPr lang="en-US" sz="1000" dirty="0"/>
+              <a:t>F-Pace</a:t>
+            </a:r>
+          </a:p>
+          <a:p>
+            <a:r>
+              <a:rPr lang="en-US" sz="1000" dirty="0"/>
+              <a:t>F-Type</a:t>
+            </a:r>
+          </a:p>
+          <a:p>
+            <a:r>
+              <a:rPr lang="en-US" sz="1000" dirty="0"/>
+              <a:t>S-Type</a:t>
+            </a:r>
+          </a:p>
+          <a:p>
+            <a:r>
+              <a:rPr lang="en-US" sz="1000" dirty="0"/>
+              <a:t>X-Type</a:t>
+            </a:r>
+          </a:p>
+          <a:p>
+            <a:r>
+              <a:rPr lang="en-US" sz="1000" dirty="0"/>
+              <a:t>XE Range</a:t>
+            </a:r>
+          </a:p>
+          <a:p>
+            <a:r>
+              <a:rPr lang="en-US" sz="1000" dirty="0"/>
+              <a:t>XF Range</a:t>
+            </a:r>
+          </a:p>
+          <a:p>
+            <a:r>
+              <a:rPr lang="en-US" sz="1000" dirty="0"/>
+              <a:t>XJ Range</a:t>
+            </a:r>
+          </a:p>
+          <a:p>
+            <a:r>
+              <a:rPr lang="en-US" sz="1000" dirty="0"/>
+              <a:t>XJS Coupe/Convertible</a:t>
+            </a:r>
+            <a:br>
+              <a:rPr lang="en-US" sz="1000" dirty="0"/>
+            </a:br>
+            <a:r>
+              <a:rPr lang="en-US" sz="1000" dirty="0"/>
+              <a:t>XK Range (Modern)</a:t>
+            </a:r>
+            <a:endParaRPr lang="LID4096" sz="1000" dirty="0"/>
+          </a:p>
+        </p:txBody>
+      </p:sp>
+      <p:sp>
+        <p:nvSpPr>
+          <p:cNvPr id="3" name="TextBox 2">
+            <a:extLst>
+              <a:ext uri="{FF2B5EF4-FFF2-40B4-BE49-F238E27FC236}">
+                <a16:creationId xmlns:a16="http://schemas.microsoft.com/office/drawing/2014/main" id="{DB79B051-D309-6F3D-C556-265C4A23AC2D}"/>
+              </a:ext>
+            </a:extLst>
+          </p:cNvPr>
+          <p:cNvSpPr txBox="1"/>
+          <p:nvPr/>
+        </p:nvSpPr>
+        <p:spPr>
+          <a:xfrm>
+            <a:off x="418579" y="3178400"/>
+            <a:ext cx="265901" cy="261610"/>
+          </a:xfrm>
+          <a:prstGeom prst="rect">
+            <a:avLst/>
+          </a:prstGeom>
+          <a:noFill/>
+        </p:spPr>
+        <p:txBody>
+          <a:bodyPr wrap="square" rtlCol="0">
+            <a:spAutoFit/>
+          </a:bodyPr>
+          <a:lstStyle/>
+          <a:p>
+            <a:r>
+              <a:rPr lang="en-US" sz="1050" dirty="0"/>
+              <a:t>*</a:t>
+            </a:r>
+            <a:endParaRPr lang="LID4096" sz="1050" dirty="0"/>
+          </a:p>
+        </p:txBody>
+      </p:sp>
+      <p:sp>
+        <p:nvSpPr>
+          <p:cNvPr id="5" name="TextBox 4">
+            <a:extLst>
+              <a:ext uri="{FF2B5EF4-FFF2-40B4-BE49-F238E27FC236}">
+                <a16:creationId xmlns:a16="http://schemas.microsoft.com/office/drawing/2014/main" id="{23532A01-223B-A6C7-014B-B2FB1D8D6A5C}"/>
+              </a:ext>
+            </a:extLst>
+          </p:cNvPr>
+          <p:cNvSpPr txBox="1"/>
+          <p:nvPr/>
+        </p:nvSpPr>
+        <p:spPr>
+          <a:xfrm>
+            <a:off x="3688206" y="777544"/>
+            <a:ext cx="3752994" cy="646331"/>
+          </a:xfrm>
+          <a:prstGeom prst="rect">
+            <a:avLst/>
+          </a:prstGeom>
+          <a:noFill/>
+        </p:spPr>
+        <p:txBody>
+          <a:bodyPr wrap="square">
+            <a:spAutoFit/>
+          </a:bodyPr>
+          <a:lstStyle/>
+          <a:p>
+            <a:r>
+              <a:rPr lang="en-US" sz="1200" dirty="0">
+                <a:solidFill>
+                  <a:schemeClr val="tx2">
+                    <a:lumMod val="50000"/>
+                    <a:lumOff val="50000"/>
+                  </a:schemeClr>
+                </a:solidFill>
+              </a:rPr>
+              <a:t>Suitability:</a:t>
+            </a:r>
+            <a:br>
+              <a:rPr lang="en-US" sz="1200" dirty="0">
+                <a:solidFill>
+                  <a:schemeClr val="tx2">
+                    <a:lumMod val="50000"/>
+                    <a:lumOff val="50000"/>
+                  </a:schemeClr>
+                </a:solidFill>
+              </a:rPr>
+            </a:br>
+            <a:r>
+              <a:rPr lang="en-US" sz="1200" dirty="0">
+                <a:solidFill>
+                  <a:schemeClr val="tx2">
+                    <a:lumMod val="50000"/>
+                    <a:lumOff val="50000"/>
+                  </a:schemeClr>
+                </a:solidFill>
+              </a:rPr>
+              <a:t>[Scrolling list]</a:t>
+            </a:r>
+          </a:p>
+          <a:p>
+            <a:r>
+              <a:rPr lang="en-US" sz="1200" dirty="0">
+                <a:solidFill>
+                  <a:schemeClr val="tx2">
+                    <a:lumMod val="50000"/>
+                    <a:lumOff val="50000"/>
+                  </a:schemeClr>
+                </a:solidFill>
+              </a:rPr>
+              <a:t>[&lt;Models&gt;&lt;</a:t>
+            </a:r>
+            <a:r>
+              <a:rPr lang="en-US" sz="1200" dirty="0" err="1">
+                <a:solidFill>
+                  <a:schemeClr val="tx2">
+                    <a:lumMod val="50000"/>
+                    <a:lumOff val="50000"/>
+                  </a:schemeClr>
+                </a:solidFill>
+              </a:rPr>
+              <a:t>ModelYear</a:t>
+            </a:r>
+            <a:r>
+              <a:rPr lang="en-US" sz="1200" dirty="0">
+                <a:solidFill>
+                  <a:schemeClr val="tx2">
+                    <a:lumMod val="50000"/>
+                    <a:lumOff val="50000"/>
+                  </a:schemeClr>
+                </a:solidFill>
+              </a:rPr>
+              <a:t>&gt;&lt;</a:t>
+            </a:r>
+            <a:r>
+              <a:rPr lang="en-US" sz="1200" dirty="0" err="1">
+                <a:solidFill>
+                  <a:schemeClr val="tx2">
+                    <a:lumMod val="50000"/>
+                    <a:lumOff val="50000"/>
+                  </a:schemeClr>
+                </a:solidFill>
+              </a:rPr>
+              <a:t>VINRanges</a:t>
+            </a:r>
+            <a:r>
+              <a:rPr lang="en-US" sz="1200" dirty="0">
+                <a:solidFill>
+                  <a:schemeClr val="tx2">
+                    <a:lumMod val="50000"/>
+                    <a:lumOff val="50000"/>
+                  </a:schemeClr>
+                </a:solidFill>
+              </a:rPr>
+              <a:t>&gt;&lt;</a:t>
+            </a:r>
+            <a:r>
+              <a:rPr lang="en-US" sz="1200" dirty="0" err="1">
+                <a:solidFill>
+                  <a:schemeClr val="tx2">
+                    <a:lumMod val="50000"/>
+                    <a:lumOff val="50000"/>
+                  </a:schemeClr>
+                </a:solidFill>
+              </a:rPr>
+              <a:t>specificatios</a:t>
+            </a:r>
+            <a:r>
+              <a:rPr lang="en-US" sz="1200" dirty="0">
+                <a:solidFill>
+                  <a:schemeClr val="tx2">
+                    <a:lumMod val="50000"/>
+                    <a:lumOff val="50000"/>
+                  </a:schemeClr>
+                </a:solidFill>
+              </a:rPr>
+              <a:t>&gt;]</a:t>
+            </a:r>
+            <a:endParaRPr lang="LID4096" sz="1200" dirty="0">
+              <a:solidFill>
+                <a:schemeClr val="tx2">
+                  <a:lumMod val="50000"/>
+                  <a:lumOff val="50000"/>
+                </a:schemeClr>
+              </a:solidFill>
+            </a:endParaRPr>
+          </a:p>
+        </p:txBody>
+      </p:sp>
+      <p:sp>
+        <p:nvSpPr>
+          <p:cNvPr id="8" name="TextBox 7">
+            <a:extLst>
+              <a:ext uri="{FF2B5EF4-FFF2-40B4-BE49-F238E27FC236}">
+                <a16:creationId xmlns:a16="http://schemas.microsoft.com/office/drawing/2014/main" id="{F4F5DBDF-2412-7614-B3C5-ECFD73253A87}"/>
+              </a:ext>
+            </a:extLst>
+          </p:cNvPr>
+          <p:cNvSpPr txBox="1"/>
+          <p:nvPr/>
+        </p:nvSpPr>
+        <p:spPr>
+          <a:xfrm>
+            <a:off x="7917289" y="815500"/>
+            <a:ext cx="2910925" cy="646331"/>
+          </a:xfrm>
+          <a:prstGeom prst="rect">
+            <a:avLst/>
+          </a:prstGeom>
+          <a:noFill/>
+        </p:spPr>
+        <p:txBody>
+          <a:bodyPr wrap="none" rtlCol="0">
+            <a:spAutoFit/>
+          </a:bodyPr>
+          <a:lstStyle/>
+          <a:p>
+            <a:r>
+              <a:rPr lang="en-US" dirty="0">
+                <a:solidFill>
+                  <a:schemeClr val="accent6"/>
+                </a:solidFill>
+              </a:rPr>
+              <a:t>Parts tree</a:t>
+            </a:r>
+          </a:p>
+          <a:p>
+            <a:r>
+              <a:rPr lang="en-US" dirty="0">
+                <a:solidFill>
+                  <a:schemeClr val="accent6"/>
+                </a:solidFill>
+              </a:rPr>
+              <a:t>[show only relevant path(s)]</a:t>
+            </a:r>
+            <a:endParaRPr lang="LID4096" dirty="0">
+              <a:solidFill>
+                <a:schemeClr val="accent6"/>
+              </a:solidFill>
+            </a:endParaRPr>
+          </a:p>
+        </p:txBody>
+      </p:sp>
+      <p:sp>
+        <p:nvSpPr>
+          <p:cNvPr id="10" name="TextBox 9">
+            <a:extLst>
+              <a:ext uri="{FF2B5EF4-FFF2-40B4-BE49-F238E27FC236}">
+                <a16:creationId xmlns:a16="http://schemas.microsoft.com/office/drawing/2014/main" id="{BACA329E-367A-5819-5C26-75A94A008574}"/>
+              </a:ext>
+            </a:extLst>
+          </p:cNvPr>
+          <p:cNvSpPr txBox="1"/>
+          <p:nvPr/>
+        </p:nvSpPr>
+        <p:spPr>
+          <a:xfrm>
+            <a:off x="4441671" y="3399771"/>
+            <a:ext cx="2246064" cy="369332"/>
+          </a:xfrm>
+          <a:prstGeom prst="rect">
+            <a:avLst/>
+          </a:prstGeom>
+          <a:noFill/>
+        </p:spPr>
+        <p:txBody>
+          <a:bodyPr wrap="none" rtlCol="0">
+            <a:spAutoFit/>
+          </a:bodyPr>
+          <a:lstStyle/>
+          <a:p>
+            <a:r>
+              <a:rPr lang="en-US" dirty="0">
+                <a:solidFill>
+                  <a:srgbClr val="FF0000"/>
+                </a:solidFill>
+              </a:rPr>
+              <a:t>Part exploding image</a:t>
+            </a:r>
+            <a:endParaRPr lang="LID4096" dirty="0">
+              <a:solidFill>
+                <a:srgbClr val="FF0000"/>
+              </a:solidFill>
+            </a:endParaRPr>
+          </a:p>
+        </p:txBody>
+      </p:sp>
+      <p:sp>
+        <p:nvSpPr>
+          <p:cNvPr id="12" name="TextBox 11">
+            <a:extLst>
+              <a:ext uri="{FF2B5EF4-FFF2-40B4-BE49-F238E27FC236}">
+                <a16:creationId xmlns:a16="http://schemas.microsoft.com/office/drawing/2014/main" id="{150E95DA-FF3E-54C7-E8B5-8FA7445FA6C8}"/>
+              </a:ext>
+            </a:extLst>
+          </p:cNvPr>
+          <p:cNvSpPr txBox="1"/>
+          <p:nvPr/>
+        </p:nvSpPr>
+        <p:spPr>
+          <a:xfrm>
+            <a:off x="818720" y="3445938"/>
+            <a:ext cx="1728550" cy="646331"/>
+          </a:xfrm>
+          <a:prstGeom prst="rect">
+            <a:avLst/>
+          </a:prstGeom>
+          <a:noFill/>
+        </p:spPr>
+        <p:txBody>
+          <a:bodyPr wrap="none" rtlCol="0">
+            <a:spAutoFit/>
+          </a:bodyPr>
+          <a:lstStyle/>
+          <a:p>
+            <a:r>
+              <a:rPr lang="en-US" dirty="0">
+                <a:solidFill>
+                  <a:srgbClr val="FFC000"/>
+                </a:solidFill>
+              </a:rPr>
+              <a:t>Location at car:</a:t>
+            </a:r>
+          </a:p>
+          <a:p>
+            <a:r>
+              <a:rPr lang="en-US" dirty="0">
+                <a:solidFill>
+                  <a:srgbClr val="FFC000"/>
+                </a:solidFill>
+              </a:rPr>
+              <a:t>Front, Middle</a:t>
+            </a:r>
+            <a:endParaRPr lang="LID4096" dirty="0">
+              <a:solidFill>
+                <a:srgbClr val="FFC000"/>
+              </a:solidFill>
+            </a:endParaRPr>
+          </a:p>
+        </p:txBody>
+      </p:sp>
+      <p:sp>
+        <p:nvSpPr>
+          <p:cNvPr id="16" name="TextBox 15">
+            <a:extLst>
+              <a:ext uri="{FF2B5EF4-FFF2-40B4-BE49-F238E27FC236}">
+                <a16:creationId xmlns:a16="http://schemas.microsoft.com/office/drawing/2014/main" id="{9F71D180-810F-6A5D-42B5-6CE7AC5FFE2F}"/>
+              </a:ext>
+            </a:extLst>
+          </p:cNvPr>
+          <p:cNvSpPr txBox="1"/>
+          <p:nvPr/>
+        </p:nvSpPr>
+        <p:spPr>
+          <a:xfrm>
+            <a:off x="696551" y="815500"/>
+            <a:ext cx="1983813" cy="523220"/>
+          </a:xfrm>
+          <a:prstGeom prst="rect">
+            <a:avLst/>
+          </a:prstGeom>
+          <a:noFill/>
+        </p:spPr>
+        <p:txBody>
+          <a:bodyPr wrap="none" rtlCol="0">
+            <a:spAutoFit/>
+          </a:bodyPr>
+          <a:lstStyle/>
+          <a:p>
+            <a:r>
+              <a:rPr lang="en-US" sz="1400" dirty="0" err="1">
+                <a:solidFill>
+                  <a:schemeClr val="tx2">
+                    <a:lumMod val="50000"/>
+                    <a:lumOff val="50000"/>
+                  </a:schemeClr>
+                </a:solidFill>
+              </a:rPr>
+              <a:t>Suitaility</a:t>
+            </a:r>
+            <a:r>
+              <a:rPr lang="en-US" sz="1400" dirty="0">
+                <a:solidFill>
+                  <a:schemeClr val="tx2">
+                    <a:lumMod val="50000"/>
+                    <a:lumOff val="50000"/>
+                  </a:schemeClr>
+                </a:solidFill>
+              </a:rPr>
+              <a:t> Model Ranges</a:t>
+            </a:r>
+          </a:p>
+          <a:p>
+            <a:r>
+              <a:rPr lang="en-US" sz="1400" dirty="0">
+                <a:solidFill>
+                  <a:schemeClr val="tx2">
+                    <a:lumMod val="50000"/>
+                    <a:lumOff val="50000"/>
+                  </a:schemeClr>
+                </a:solidFill>
+              </a:rPr>
+              <a:t>[Check Boxes show fit]</a:t>
+            </a:r>
+            <a:endParaRPr lang="LID4096" sz="1400" dirty="0">
+              <a:solidFill>
+                <a:schemeClr val="tx2">
+                  <a:lumMod val="50000"/>
+                  <a:lumOff val="50000"/>
+                </a:schemeClr>
+              </a:solidFill>
+            </a:endParaRPr>
+          </a:p>
+        </p:txBody>
+      </p:sp>
+    </p:spTree>
+    <p:extLst>
+      <p:ext uri="{BB962C8B-B14F-4D97-AF65-F5344CB8AC3E}">
+        <p14:creationId xmlns:p14="http://schemas.microsoft.com/office/powerpoint/2010/main" val="1388509897"/>
+      </p:ext>
+    </p:extLst>
+  </p:cSld>
+  <p:clrMapOvr>
+    <a:masterClrMapping/>
+  </p:clrMapOvr>
+</p:sld>
+</file>
+
+<file path=ppt/slides/slide2.xml><?xml version="1.0" encoding="utf-8"?>
+<p:sld xmlns:a="http://schemas.openxmlformats.org/drawingml/2006/main" xmlns:r="http://schemas.openxmlformats.org/officeDocument/2006/relationships" xmlns:p="http://schemas.openxmlformats.org/presentationml/2006/main">
+  <p:cSld>
+    <p:spTree>
+      <p:nvGrpSpPr>
+        <p:cNvPr id="1" name=""/>
+        <p:cNvGrpSpPr/>
+        <p:nvPr/>
+      </p:nvGrpSpPr>
+      <p:grpSpPr>
+        <a:xfrm>
+          <a:off x="0" y="0"/>
+          <a:ext cx="0" cy="0"/>
+          <a:chOff x="0" y="0"/>
+          <a:chExt cx="0" cy="0"/>
+        </a:xfrm>
+      </p:grpSpPr>
+      <p:pic>
+        <p:nvPicPr>
+          <p:cNvPr id="13" name="Picture 12">
+            <a:extLst>
+              <a:ext uri="{FF2B5EF4-FFF2-40B4-BE49-F238E27FC236}">
+                <a16:creationId xmlns:a16="http://schemas.microsoft.com/office/drawing/2014/main" id="{917D9344-98BA-1301-286A-B95D2C81DE37}"/>
+              </a:ext>
+            </a:extLst>
+          </p:cNvPr>
+          <p:cNvPicPr>
+            <a:picLocks noChangeAspect="1"/>
+          </p:cNvPicPr>
+          <p:nvPr/>
+        </p:nvPicPr>
+        <p:blipFill>
+          <a:blip r:embed="rId2"/>
+          <a:srcRect t="11758" b="3184"/>
+          <a:stretch>
+            <a:fillRect/>
+          </a:stretch>
+        </p:blipFill>
+        <p:spPr>
+          <a:xfrm>
             <a:off x="4430195" y="1403725"/>
             <a:ext cx="2932066" cy="3190225"/>
           </a:xfrm>
@@ -4364,7 +5031,7 @@
 </p:sld>
 </file>
 
-<file path=ppt/slides/slide2.xml><?xml version="1.0" encoding="utf-8"?>
+<file path=ppt/slides/slide3.xml><?xml version="1.0" encoding="utf-8"?>
 <p:sld xmlns:a="http://schemas.openxmlformats.org/drawingml/2006/main" xmlns:r="http://schemas.openxmlformats.org/officeDocument/2006/relationships" xmlns:p="http://schemas.openxmlformats.org/presentationml/2006/main">
   <p:cSld>
     <p:spTree>
@@ -5138,7 +5805,7 @@
 </p:sld>
 </file>
 
-<file path=ppt/slides/slide3.xml><?xml version="1.0" encoding="utf-8"?>
+<file path=ppt/slides/slide4.xml><?xml version="1.0" encoding="utf-8"?>
 <p:sld xmlns:a="http://schemas.openxmlformats.org/drawingml/2006/main" xmlns:r="http://schemas.openxmlformats.org/officeDocument/2006/relationships" xmlns:p="http://schemas.openxmlformats.org/presentationml/2006/main">
   <p:cSld>
     <p:spTree>

</xml_diff>